<commit_message>
avancée projet 6 avant mentorat
</commit_message>
<xml_diff>
--- a/Data_Analyst/Projet_6/ModeĖle_preėsentation-Bottleneck.pptx
+++ b/Data_Analyst/Projet_6/ModeĖle_preėsentation-Bottleneck.pptx
@@ -292,10 +292,54 @@
       </p15:sldGuideLst>
     </p:ext>
     <p:ext uri="http://customooxmlschemas.google.com/">
-      <go:slidesCustomData xmlns:go="http://customooxmlschemas.google.com/" xmlns:ahyp="http://schemas.microsoft.com/office/drawing/2018/hyperlinkcolor" xmlns:p15="http://schemas.microsoft.com/office/powerpoint/2012/main" xmlns:p14="http://schemas.microsoft.com/office/powerpoint/2010/main" xmlns:com="http://schemas.openxmlformats.org/drawingml/2006/compatibility" xmlns:pvml="urn:schemas-microsoft-com:office:powerpoint" xmlns:v="urn:schemas-microsoft-com:vml" xmlns:o="urn:schemas-microsoft-com:office:office" xmlns:dgm="http://schemas.openxmlformats.org/drawingml/2006/diagram" xmlns:c="http://schemas.openxmlformats.org/drawingml/2006/chart" xmlns:mv="urn:schemas-microsoft-com:mac:vml" xmlns:mc="http://schemas.openxmlformats.org/markup-compatibility/2006" xmlns="" r:id="rId17" roundtripDataSignature="AMtx7miohyEog1akfKJRRdWquyApPmpApA=="/>
+      <go:slidesCustomData xmlns="" xmlns:mc="http://schemas.openxmlformats.org/markup-compatibility/2006" xmlns:mv="urn:schemas-microsoft-com:mac:vml" xmlns:c="http://schemas.openxmlformats.org/drawingml/2006/chart" xmlns:dgm="http://schemas.openxmlformats.org/drawingml/2006/diagram" xmlns:o="urn:schemas-microsoft-com:office:office" xmlns:v="urn:schemas-microsoft-com:vml" xmlns:pvml="urn:schemas-microsoft-com:office:powerpoint" xmlns:com="http://schemas.openxmlformats.org/drawingml/2006/compatibility" xmlns:p14="http://schemas.microsoft.com/office/powerpoint/2010/main" xmlns:p15="http://schemas.microsoft.com/office/powerpoint/2012/main" xmlns:ahyp="http://schemas.microsoft.com/office/drawing/2018/hyperlinkcolor" xmlns:go="http://customooxmlschemas.google.com/" r:id="rId17" roundtripDataSignature="AMtx7miohyEog1akfKJRRdWquyApPmpApA=="/>
     </p:ext>
   </p:extLst>
 </p:presentation>
+</file>
+
+<file path=ppt/changesInfos/changesInfo1.xml><?xml version="1.0" encoding="utf-8"?>
+<pc:chgInfo xmlns:a="http://schemas.openxmlformats.org/drawingml/2006/main" xmlns:r="http://schemas.openxmlformats.org/officeDocument/2006/relationships" xmlns:ac="http://schemas.microsoft.com/office/drawing/2013/main/command" xmlns:pc="http://schemas.microsoft.com/office/powerpoint/2013/main/command">
+  <pc:docChgLst>
+    <pc:chgData name="Zied Belhocine" userId="200cc0e2b299676e" providerId="LiveId" clId="{3EBBFEB4-7E60-440A-B139-E25F34F33931}"/>
+    <pc:docChg chg="modSld">
+      <pc:chgData name="Zied Belhocine" userId="200cc0e2b299676e" providerId="LiveId" clId="{3EBBFEB4-7E60-440A-B139-E25F34F33931}" dt="2026-03-11T12:37:09.708" v="10" actId="13926"/>
+      <pc:docMkLst>
+        <pc:docMk/>
+      </pc:docMkLst>
+      <pc:sldChg chg="modSp mod">
+        <pc:chgData name="Zied Belhocine" userId="200cc0e2b299676e" providerId="LiveId" clId="{3EBBFEB4-7E60-440A-B139-E25F34F33931}" dt="2026-03-11T12:36:57.389" v="5" actId="13926"/>
+        <pc:sldMkLst>
+          <pc:docMk/>
+          <pc:sldMk cId="0" sldId="257"/>
+        </pc:sldMkLst>
+        <pc:spChg chg="mod">
+          <ac:chgData name="Zied Belhocine" userId="200cc0e2b299676e" providerId="LiveId" clId="{3EBBFEB4-7E60-440A-B139-E25F34F33931}" dt="2026-03-11T12:36:57.389" v="5" actId="13926"/>
+          <ac:spMkLst>
+            <pc:docMk/>
+            <pc:sldMk cId="0" sldId="257"/>
+            <ac:spMk id="63" creationId="{00000000-0000-0000-0000-000000000000}"/>
+          </ac:spMkLst>
+        </pc:spChg>
+      </pc:sldChg>
+      <pc:sldChg chg="modSp mod">
+        <pc:chgData name="Zied Belhocine" userId="200cc0e2b299676e" providerId="LiveId" clId="{3EBBFEB4-7E60-440A-B139-E25F34F33931}" dt="2026-03-11T12:37:09.708" v="10" actId="13926"/>
+        <pc:sldMkLst>
+          <pc:docMk/>
+          <pc:sldMk cId="0" sldId="258"/>
+        </pc:sldMkLst>
+        <pc:spChg chg="mod">
+          <ac:chgData name="Zied Belhocine" userId="200cc0e2b299676e" providerId="LiveId" clId="{3EBBFEB4-7E60-440A-B139-E25F34F33931}" dt="2026-03-11T12:37:09.708" v="10" actId="13926"/>
+          <ac:spMkLst>
+            <pc:docMk/>
+            <pc:sldMk cId="0" sldId="258"/>
+            <ac:spMk id="71" creationId="{00000000-0000-0000-0000-000000000000}"/>
+          </ac:spMkLst>
+        </pc:spChg>
+      </pc:sldChg>
+    </pc:docChg>
+  </pc:docChgLst>
+</pc:chgInfo>
 </file>
 
 <file path=ppt/notesMasters/notesMaster1.xml><?xml version="1.0" encoding="utf-8"?>
@@ -9961,7 +10005,7 @@
               <a:buChar char="●"/>
             </a:pPr>
             <a:r>
-              <a:rPr lang="fr" i="1">
+              <a:rPr lang="fr" i="1" dirty="0">
                 <a:solidFill>
                   <a:srgbClr val="999999"/>
                 </a:solidFill>
@@ -9972,7 +10016,7 @@
               </a:rPr>
               <a:t>Datasets</a:t>
             </a:r>
-            <a:endParaRPr i="1">
+            <a:endParaRPr i="1" dirty="0">
               <a:solidFill>
                 <a:srgbClr val="999999"/>
               </a:solidFill>
@@ -10001,7 +10045,7 @@
               <a:buChar char="●"/>
             </a:pPr>
             <a:r>
-              <a:rPr lang="fr" i="1">
+              <a:rPr lang="fr" i="1" dirty="0">
                 <a:solidFill>
                   <a:srgbClr val="999999"/>
                 </a:solidFill>
@@ -10012,7 +10056,7 @@
               </a:rPr>
               <a:t>Caractéristiques</a:t>
             </a:r>
-            <a:endParaRPr i="1">
+            <a:endParaRPr i="1" dirty="0">
               <a:solidFill>
                 <a:srgbClr val="999999"/>
               </a:solidFill>
@@ -10041,7 +10085,7 @@
               <a:buChar char="●"/>
             </a:pPr>
             <a:r>
-              <a:rPr lang="fr" i="1">
+              <a:rPr lang="fr" i="1" dirty="0">
                 <a:solidFill>
                   <a:srgbClr val="999999"/>
                 </a:solidFill>
@@ -10052,7 +10096,7 @@
               </a:rPr>
               <a:t>Traitement réalisés</a:t>
             </a:r>
-            <a:endParaRPr i="1">
+            <a:endParaRPr i="1" dirty="0">
               <a:solidFill>
                 <a:srgbClr val="999999"/>
               </a:solidFill>
@@ -10081,7 +10125,7 @@
               <a:buChar char="○"/>
             </a:pPr>
             <a:r>
-              <a:rPr lang="fr" sz="1800" i="1">
+              <a:rPr lang="fr" sz="1800" i="1" dirty="0">
                 <a:solidFill>
                   <a:srgbClr val="999999"/>
                 </a:solidFill>
@@ -10092,7 +10136,7 @@
               </a:rPr>
               <a:t>Nettoyages des données</a:t>
             </a:r>
-            <a:endParaRPr sz="1800" i="1">
+            <a:endParaRPr sz="1800" i="1" dirty="0">
               <a:solidFill>
                 <a:srgbClr val="999999"/>
               </a:solidFill>
@@ -10121,21 +10165,27 @@
               <a:buChar char="○"/>
             </a:pPr>
             <a:r>
-              <a:rPr lang="fr" sz="1800" i="1">
+              <a:rPr lang="fr" sz="1800" i="1" dirty="0">
                 <a:solidFill>
                   <a:srgbClr val="999999"/>
                 </a:solidFill>
+                <a:highlight>
+                  <a:srgbClr val="FFFF00"/>
+                </a:highlight>
                 <a:latin typeface="Montserrat"/>
                 <a:ea typeface="Montserrat"/>
                 <a:cs typeface="Montserrat"/>
                 <a:sym typeface="Montserrat"/>
               </a:rPr>
-              <a:t>Features engineering</a:t>
+              <a:t>Features engineering ????</a:t>
             </a:r>
-            <a:endParaRPr sz="1800" i="1">
+            <a:endParaRPr sz="1800" i="1" dirty="0">
               <a:solidFill>
                 <a:srgbClr val="999999"/>
               </a:solidFill>
+              <a:highlight>
+                <a:srgbClr val="FFFF00"/>
+              </a:highlight>
               <a:latin typeface="Montserrat"/>
               <a:ea typeface="Montserrat"/>
               <a:cs typeface="Montserrat"/>
@@ -10161,7 +10211,7 @@
               <a:buChar char="●"/>
             </a:pPr>
             <a:r>
-              <a:rPr lang="fr" i="1">
+              <a:rPr lang="fr" i="1" dirty="0">
                 <a:solidFill>
                   <a:srgbClr val="999999"/>
                 </a:solidFill>
@@ -10172,7 +10222,7 @@
               </a:rPr>
               <a:t>Remarques éventuelles, pièges ou difficultés rencontrées </a:t>
             </a:r>
-            <a:endParaRPr i="1">
+            <a:endParaRPr i="1" dirty="0">
               <a:solidFill>
                 <a:srgbClr val="999999"/>
               </a:solidFill>
@@ -10309,7 +10359,7 @@
                 <a:sym typeface="Montserrat"/>
                 <a:extLst>
                   <a:ext uri="http://customooxmlschemas.google.com/">
-                    <go:slidesCustomData xmlns:go="http://customooxmlschemas.google.com/" xmlns:ahyp="http://schemas.microsoft.com/office/drawing/2018/hyperlinkcolor" xmlns:p15="http://schemas.microsoft.com/office/powerpoint/2012/main" xmlns:p14="http://schemas.microsoft.com/office/powerpoint/2010/main" xmlns:com="http://schemas.openxmlformats.org/drawingml/2006/compatibility" xmlns:pvml="urn:schemas-microsoft-com:office:powerpoint" xmlns:v="urn:schemas-microsoft-com:vml" xmlns:o="urn:schemas-microsoft-com:office:office" xmlns:dgm="http://schemas.openxmlformats.org/drawingml/2006/diagram" xmlns:c="http://schemas.openxmlformats.org/drawingml/2006/chart" xmlns:mv="urn:schemas-microsoft-com:mac:vml" xmlns:mc="http://schemas.openxmlformats.org/markup-compatibility/2006" xmlns="" textRoundtripDataId="0"/>
+                    <go:slidesCustomData xmlns="" xmlns:mc="http://schemas.openxmlformats.org/markup-compatibility/2006" xmlns:mv="urn:schemas-microsoft-com:mac:vml" xmlns:c="http://schemas.openxmlformats.org/drawingml/2006/chart" xmlns:dgm="http://schemas.openxmlformats.org/drawingml/2006/diagram" xmlns:o="urn:schemas-microsoft-com:office:office" xmlns:v="urn:schemas-microsoft-com:vml" xmlns:pvml="urn:schemas-microsoft-com:office:powerpoint" xmlns:com="http://schemas.openxmlformats.org/drawingml/2006/compatibility" xmlns:p14="http://schemas.microsoft.com/office/powerpoint/2010/main" xmlns:p15="http://schemas.microsoft.com/office/powerpoint/2012/main" xmlns:ahyp="http://schemas.microsoft.com/office/drawing/2018/hyperlinkcolor" xmlns:go="http://customooxmlschemas.google.com/" textRoundtripDataId="0"/>
                   </a:ext>
                 </a:extLst>
               </a:rPr>
@@ -10326,7 +10376,7 @@
                 <a:sym typeface="Montserrat"/>
                 <a:extLst>
                   <a:ext uri="http://customooxmlschemas.google.com/">
-                    <go:slidesCustomData xmlns:go="http://customooxmlschemas.google.com/" xmlns:ahyp="http://schemas.microsoft.com/office/drawing/2018/hyperlinkcolor" xmlns:p15="http://schemas.microsoft.com/office/powerpoint/2012/main" xmlns:p14="http://schemas.microsoft.com/office/powerpoint/2010/main" xmlns:com="http://schemas.openxmlformats.org/drawingml/2006/compatibility" xmlns:pvml="urn:schemas-microsoft-com:office:powerpoint" xmlns:v="urn:schemas-microsoft-com:vml" xmlns:o="urn:schemas-microsoft-com:office:office" xmlns:dgm="http://schemas.openxmlformats.org/drawingml/2006/diagram" xmlns:c="http://schemas.openxmlformats.org/drawingml/2006/chart" xmlns:mv="urn:schemas-microsoft-com:mac:vml" xmlns:mc="http://schemas.openxmlformats.org/markup-compatibility/2006" xmlns="" textRoundtripDataId="1"/>
+                    <go:slidesCustomData xmlns="" xmlns:mc="http://schemas.openxmlformats.org/markup-compatibility/2006" xmlns:mv="urn:schemas-microsoft-com:mac:vml" xmlns:c="http://schemas.openxmlformats.org/drawingml/2006/chart" xmlns:dgm="http://schemas.openxmlformats.org/drawingml/2006/diagram" xmlns:o="urn:schemas-microsoft-com:office:office" xmlns:v="urn:schemas-microsoft-com:vml" xmlns:pvml="urn:schemas-microsoft-com:office:powerpoint" xmlns:com="http://schemas.openxmlformats.org/drawingml/2006/compatibility" xmlns:p14="http://schemas.microsoft.com/office/powerpoint/2010/main" xmlns:p15="http://schemas.microsoft.com/office/powerpoint/2012/main" xmlns:ahyp="http://schemas.microsoft.com/office/drawing/2018/hyperlinkcolor" xmlns:go="http://customooxmlschemas.google.com/" textRoundtripDataId="1"/>
                   </a:ext>
                 </a:extLst>
               </a:rPr>
@@ -10343,7 +10393,7 @@
                 <a:sym typeface="Montserrat"/>
                 <a:extLst>
                   <a:ext uri="http://customooxmlschemas.google.com/">
-                    <go:slidesCustomData xmlns:go="http://customooxmlschemas.google.com/" xmlns:ahyp="http://schemas.microsoft.com/office/drawing/2018/hyperlinkcolor" xmlns:p15="http://schemas.microsoft.com/office/powerpoint/2012/main" xmlns:p14="http://schemas.microsoft.com/office/powerpoint/2010/main" xmlns:com="http://schemas.openxmlformats.org/drawingml/2006/compatibility" xmlns:pvml="urn:schemas-microsoft-com:office:powerpoint" xmlns:v="urn:schemas-microsoft-com:vml" xmlns:o="urn:schemas-microsoft-com:office:office" xmlns:dgm="http://schemas.openxmlformats.org/drawingml/2006/diagram" xmlns:c="http://schemas.openxmlformats.org/drawingml/2006/chart" xmlns:mv="urn:schemas-microsoft-com:mac:vml" xmlns:mc="http://schemas.openxmlformats.org/markup-compatibility/2006" xmlns="" textRoundtripDataId="2"/>
+                    <go:slidesCustomData xmlns="" xmlns:mc="http://schemas.openxmlformats.org/markup-compatibility/2006" xmlns:mv="urn:schemas-microsoft-com:mac:vml" xmlns:c="http://schemas.openxmlformats.org/drawingml/2006/chart" xmlns:dgm="http://schemas.openxmlformats.org/drawingml/2006/diagram" xmlns:o="urn:schemas-microsoft-com:office:office" xmlns:v="urn:schemas-microsoft-com:vml" xmlns:pvml="urn:schemas-microsoft-com:office:powerpoint" xmlns:com="http://schemas.openxmlformats.org/drawingml/2006/compatibility" xmlns:p14="http://schemas.microsoft.com/office/powerpoint/2010/main" xmlns:p15="http://schemas.microsoft.com/office/powerpoint/2012/main" xmlns:ahyp="http://schemas.microsoft.com/office/drawing/2018/hyperlinkcolor" xmlns:go="http://customooxmlschemas.google.com/" textRoundtripDataId="2"/>
                   </a:ext>
                 </a:extLst>
               </a:rPr>
@@ -10489,18 +10539,64 @@
               <a:buChar char="●"/>
             </a:pPr>
             <a:r>
-              <a:rPr lang="fr" i="1">
+              <a:rPr lang="fr" i="1" dirty="0">
                 <a:solidFill>
                   <a:srgbClr val="999999"/>
                 </a:solidFill>
+                <a:highlight>
+                  <a:srgbClr val="FFFF00"/>
+                </a:highlight>
                 <a:latin typeface="Montserrat"/>
                 <a:ea typeface="Montserrat"/>
                 <a:cs typeface="Montserrat"/>
                 <a:sym typeface="Montserrat"/>
               </a:rPr>
-              <a:t>Choix des attributs</a:t>
+              <a:t>Choix des attributs ???</a:t>
             </a:r>
-            <a:endParaRPr i="1">
+            <a:endParaRPr i="1" dirty="0">
+              <a:solidFill>
+                <a:srgbClr val="999999"/>
+              </a:solidFill>
+              <a:highlight>
+                <a:srgbClr val="FFFF00"/>
+              </a:highlight>
+              <a:latin typeface="Montserrat"/>
+              <a:ea typeface="Montserrat"/>
+              <a:cs typeface="Montserrat"/>
+              <a:sym typeface="Montserrat"/>
+            </a:endParaRPr>
+          </a:p>
+          <a:p>
+            <a:pPr marL="457200" marR="0" lvl="0" indent="-342900" algn="l" rtl="0">
+              <a:lnSpc>
+                <a:spcPct val="115000"/>
+              </a:lnSpc>
+              <a:spcBef>
+                <a:spcPts val="0"/>
+              </a:spcBef>
+              <a:spcAft>
+                <a:spcPts val="0"/>
+              </a:spcAft>
+              <a:buClr>
+                <a:srgbClr val="999999"/>
+              </a:buClr>
+              <a:buSzPts val="1800"/>
+              <a:buFont typeface="Montserrat"/>
+              <a:buChar char="●"/>
+            </a:pPr>
+            <a:r>
+              <a:rPr lang="fr" i="1" dirty="0">
+                <a:solidFill>
+                  <a:srgbClr val="999999"/>
+                </a:solidFill>
+                <a:latin typeface="Montserrat"/>
+                <a:ea typeface="Montserrat"/>
+                <a:cs typeface="Montserrat"/>
+                <a:sym typeface="Montserrat"/>
+              </a:rPr>
+              <a:t>Clés utilisés</a:t>
+            </a:r>
+            <a:endParaRPr i="1" dirty="0">
               <a:solidFill>
                 <a:srgbClr val="999999"/>
               </a:solidFill>
@@ -10529,7 +10625,7 @@
               <a:buChar char="●"/>
             </a:pPr>
             <a:r>
-              <a:rPr lang="fr" i="1">
+              <a:rPr lang="fr" i="1" dirty="0">
                 <a:solidFill>
                   <a:srgbClr val="999999"/>
                 </a:solidFill>
@@ -10538,9 +10634,9 @@
                 <a:cs typeface="Montserrat"/>
                 <a:sym typeface="Montserrat"/>
               </a:rPr>
-              <a:t>Clés utilisés</a:t>
+              <a:t>Vigilances particulières au cours du traitements</a:t>
             </a:r>
-            <a:endParaRPr i="1">
+            <a:endParaRPr i="1" dirty="0">
               <a:solidFill>
                 <a:srgbClr val="999999"/>
               </a:solidFill>
@@ -10569,47 +10665,7 @@
               <a:buChar char="●"/>
             </a:pPr>
             <a:r>
-              <a:rPr lang="fr" i="1">
-                <a:solidFill>
-                  <a:srgbClr val="999999"/>
-                </a:solidFill>
-                <a:latin typeface="Montserrat"/>
-                <a:ea typeface="Montserrat"/>
-                <a:cs typeface="Montserrat"/>
-                <a:sym typeface="Montserrat"/>
-              </a:rPr>
-              <a:t>Vigilances particulières au cours du traitements</a:t>
-            </a:r>
-            <a:endParaRPr i="1">
-              <a:solidFill>
-                <a:srgbClr val="999999"/>
-              </a:solidFill>
-              <a:latin typeface="Montserrat"/>
-              <a:ea typeface="Montserrat"/>
-              <a:cs typeface="Montserrat"/>
-              <a:sym typeface="Montserrat"/>
-            </a:endParaRPr>
-          </a:p>
-          <a:p>
-            <a:pPr marL="457200" marR="0" lvl="0" indent="-342900" algn="l" rtl="0">
-              <a:lnSpc>
-                <a:spcPct val="115000"/>
-              </a:lnSpc>
-              <a:spcBef>
-                <a:spcPts val="0"/>
-              </a:spcBef>
-              <a:spcAft>
-                <a:spcPts val="0"/>
-              </a:spcAft>
-              <a:buClr>
-                <a:srgbClr val="999999"/>
-              </a:buClr>
-              <a:buSzPts val="1800"/>
-              <a:buFont typeface="Montserrat"/>
-              <a:buChar char="●"/>
-            </a:pPr>
-            <a:r>
-              <a:rPr lang="fr" i="1">
+              <a:rPr lang="fr" i="1" dirty="0">
                 <a:solidFill>
                   <a:srgbClr val="999999"/>
                 </a:solidFill>
@@ -10620,7 +10676,7 @@
               </a:rPr>
               <a:t>Difficultés ou pièges rencontrés</a:t>
             </a:r>
-            <a:endParaRPr/>
+            <a:endParaRPr dirty="0"/>
           </a:p>
           <a:p>
             <a:pPr marL="114300" lvl="0" indent="0" algn="l" rtl="0">
@@ -10639,7 +10695,7 @@
               <a:buSzPts val="1800"/>
               <a:buNone/>
             </a:pPr>
-            <a:endParaRPr>
+            <a:endParaRPr dirty="0">
               <a:solidFill>
                 <a:srgbClr val="434343"/>
               </a:solidFill>

</xml_diff>